<commit_message>
Config added and themes
</commit_message>
<xml_diff>
--- a/Projekt.pptx
+++ b/Projekt.pptx
@@ -5,15 +5,17 @@
     <p:sldMasterId id="2147483708" r:id="rId3"/>
   </p:sldMasterIdLst>
   <p:notesMasterIdLst>
-    <p:notesMasterId r:id="rId5"/>
+    <p:notesMasterId r:id="rId7"/>
   </p:notesMasterIdLst>
   <p:sldIdLst>
     <p:sldId id="256" r:id="rId4"/>
+    <p:sldId id="258" r:id="rId5"/>
+    <p:sldId id="257" r:id="rId6"/>
   </p:sldIdLst>
   <p:sldSz cx="10969625" cy="6170613"/>
   <p:notesSz cx="6858000" cy="9144000"/>
   <p:custDataLst>
-    <p:tags r:id="rId6"/>
+    <p:tags r:id="rId8"/>
   </p:custDataLst>
   <p:defaultTextStyle>
     <a:defPPr>
@@ -8717,6 +8719,228 @@
     <p:extLst>
       <p:ext uri="{BB962C8B-B14F-4D97-AF65-F5344CB8AC3E}">
         <p14:creationId xmlns:p14="http://schemas.microsoft.com/office/powerpoint/2010/main" val="28530264"/>
+      </p:ext>
+    </p:extLst>
+  </p:cSld>
+  <p:clrMapOvr>
+    <a:masterClrMapping/>
+  </p:clrMapOvr>
+</p:sld>
+</file>
+
+<file path=ppt/slides/slide2.xml><?xml version="1.0" encoding="utf-8"?>
+<p:sld xmlns:a="http://schemas.openxmlformats.org/drawingml/2006/main" xmlns:r="http://schemas.openxmlformats.org/officeDocument/2006/relationships" xmlns:p="http://schemas.openxmlformats.org/presentationml/2006/main">
+  <p:cSld>
+    <p:spTree>
+      <p:nvGrpSpPr>
+        <p:cNvPr id="1" name=""/>
+        <p:cNvGrpSpPr/>
+        <p:nvPr/>
+      </p:nvGrpSpPr>
+      <p:grpSpPr>
+        <a:xfrm>
+          <a:off x="0" y="0"/>
+          <a:ext cx="0" cy="0"/>
+          <a:chOff x="0" y="0"/>
+          <a:chExt cx="0" cy="0"/>
+        </a:xfrm>
+      </p:grpSpPr>
+      <p:sp>
+        <p:nvSpPr>
+          <p:cNvPr id="2" name="Titel 1">
+            <a:extLst>
+              <a:ext uri="{FF2B5EF4-FFF2-40B4-BE49-F238E27FC236}">
+                <a16:creationId xmlns:a16="http://schemas.microsoft.com/office/drawing/2014/main" id="{DBC9E838-8CED-59EE-6386-785FB16D1927}"/>
+              </a:ext>
+            </a:extLst>
+          </p:cNvPr>
+          <p:cNvSpPr>
+            <a:spLocks noGrp="1"/>
+          </p:cNvSpPr>
+          <p:nvPr>
+            <p:ph type="ctrTitle"/>
+          </p:nvPr>
+        </p:nvSpPr>
+        <p:spPr>
+          <a:xfrm>
+            <a:off x="4547871" y="312615"/>
+            <a:ext cx="4572684" cy="508016"/>
+          </a:xfrm>
+        </p:spPr>
+        <p:txBody>
+          <a:bodyPr>
+            <a:normAutofit fontScale="90000"/>
+          </a:bodyPr>
+          <a:lstStyle/>
+          <a:p>
+            <a:pPr algn="ctr"/>
+            <a:r>
+              <a:rPr lang="de-DE" dirty="0"/>
+              <a:t>Agenda</a:t>
+            </a:r>
+          </a:p>
+        </p:txBody>
+      </p:sp>
+      <p:sp>
+        <p:nvSpPr>
+          <p:cNvPr id="3" name="Textplatzhalter 2">
+            <a:extLst>
+              <a:ext uri="{FF2B5EF4-FFF2-40B4-BE49-F238E27FC236}">
+                <a16:creationId xmlns:a16="http://schemas.microsoft.com/office/drawing/2014/main" id="{31A715C1-17C6-B4F1-F623-1126CF2C6BD8}"/>
+              </a:ext>
+            </a:extLst>
+          </p:cNvPr>
+          <p:cNvSpPr>
+            <a:spLocks noGrp="1"/>
+          </p:cNvSpPr>
+          <p:nvPr>
+            <p:ph type="body" sz="quarter" idx="1"/>
+          </p:nvPr>
+        </p:nvSpPr>
+        <p:spPr>
+          <a:xfrm>
+            <a:off x="4024923" y="1187939"/>
+            <a:ext cx="5447323" cy="4134338"/>
+          </a:xfrm>
+        </p:spPr>
+        <p:txBody>
+          <a:bodyPr>
+            <a:normAutofit/>
+          </a:bodyPr>
+          <a:lstStyle/>
+          <a:p>
+            <a:pPr marL="171450" indent="-171450">
+              <a:buFontTx/>
+              <a:buChar char="-"/>
+            </a:pPr>
+            <a:r>
+              <a:rPr lang="de-DE" sz="1200" dirty="0"/>
+              <a:t>Planung und Idee</a:t>
+            </a:r>
+          </a:p>
+          <a:p>
+            <a:pPr marL="171450" indent="-171450">
+              <a:buFontTx/>
+              <a:buChar char="-"/>
+            </a:pPr>
+            <a:r>
+              <a:rPr lang="de-DE" sz="1200" dirty="0"/>
+              <a:t>Erste Probleme</a:t>
+            </a:r>
+          </a:p>
+          <a:p>
+            <a:pPr marL="171450" indent="-171450">
+              <a:buFontTx/>
+              <a:buChar char="-"/>
+            </a:pPr>
+            <a:r>
+              <a:rPr lang="de-DE" sz="1200" dirty="0"/>
+              <a:t>Rechnereien</a:t>
+            </a:r>
+          </a:p>
+          <a:p>
+            <a:pPr marL="171450" indent="-171450">
+              <a:buFontTx/>
+              <a:buChar char="-"/>
+            </a:pPr>
+            <a:r>
+              <a:rPr lang="de-DE" sz="1200" dirty="0"/>
+              <a:t>Aufgabenverteilung</a:t>
+            </a:r>
+          </a:p>
+          <a:p>
+            <a:pPr marL="171450" indent="-171450">
+              <a:buFontTx/>
+              <a:buChar char="-"/>
+            </a:pPr>
+            <a:endParaRPr lang="de-DE" sz="1200" dirty="0"/>
+          </a:p>
+        </p:txBody>
+      </p:sp>
+    </p:spTree>
+    <p:extLst>
+      <p:ext uri="{BB962C8B-B14F-4D97-AF65-F5344CB8AC3E}">
+        <p14:creationId xmlns:p14="http://schemas.microsoft.com/office/powerpoint/2010/main" val="3686480338"/>
+      </p:ext>
+    </p:extLst>
+  </p:cSld>
+  <p:clrMapOvr>
+    <a:masterClrMapping/>
+  </p:clrMapOvr>
+</p:sld>
+</file>
+
+<file path=ppt/slides/slide3.xml><?xml version="1.0" encoding="utf-8"?>
+<p:sld xmlns:a="http://schemas.openxmlformats.org/drawingml/2006/main" xmlns:r="http://schemas.openxmlformats.org/officeDocument/2006/relationships" xmlns:p="http://schemas.openxmlformats.org/presentationml/2006/main">
+  <p:cSld>
+    <p:spTree>
+      <p:nvGrpSpPr>
+        <p:cNvPr id="1" name=""/>
+        <p:cNvGrpSpPr/>
+        <p:nvPr/>
+      </p:nvGrpSpPr>
+      <p:grpSpPr>
+        <a:xfrm>
+          <a:off x="0" y="0"/>
+          <a:ext cx="0" cy="0"/>
+          <a:chOff x="0" y="0"/>
+          <a:chExt cx="0" cy="0"/>
+        </a:xfrm>
+      </p:grpSpPr>
+      <p:sp>
+        <p:nvSpPr>
+          <p:cNvPr id="2" name="Textplatzhalter 1">
+            <a:extLst>
+              <a:ext uri="{FF2B5EF4-FFF2-40B4-BE49-F238E27FC236}">
+                <a16:creationId xmlns:a16="http://schemas.microsoft.com/office/drawing/2014/main" id="{45FF7F7C-209E-60F0-063E-5D1E85FAFBA7}"/>
+              </a:ext>
+            </a:extLst>
+          </p:cNvPr>
+          <p:cNvSpPr>
+            <a:spLocks noGrp="1"/>
+          </p:cNvSpPr>
+          <p:nvPr>
+            <p:ph type="body" sz="quarter" idx="15"/>
+          </p:nvPr>
+        </p:nvSpPr>
+        <p:spPr/>
+        <p:txBody>
+          <a:bodyPr/>
+          <a:lstStyle/>
+          <a:p>
+            <a:endParaRPr lang="de-DE"/>
+          </a:p>
+        </p:txBody>
+      </p:sp>
+      <p:sp>
+        <p:nvSpPr>
+          <p:cNvPr id="3" name="Titel 2">
+            <a:extLst>
+              <a:ext uri="{FF2B5EF4-FFF2-40B4-BE49-F238E27FC236}">
+                <a16:creationId xmlns:a16="http://schemas.microsoft.com/office/drawing/2014/main" id="{F4E08210-8B79-BFFD-7753-786EE524F3C4}"/>
+              </a:ext>
+            </a:extLst>
+          </p:cNvPr>
+          <p:cNvSpPr>
+            <a:spLocks noGrp="1"/>
+          </p:cNvSpPr>
+          <p:nvPr>
+            <p:ph type="ctrTitle"/>
+          </p:nvPr>
+        </p:nvSpPr>
+        <p:spPr/>
+        <p:txBody>
+          <a:bodyPr/>
+          <a:lstStyle/>
+          <a:p>
+            <a:endParaRPr lang="de-DE"/>
+          </a:p>
+        </p:txBody>
+      </p:sp>
+    </p:spTree>
+    <p:extLst>
+      <p:ext uri="{BB962C8B-B14F-4D97-AF65-F5344CB8AC3E}">
+        <p14:creationId xmlns:p14="http://schemas.microsoft.com/office/powerpoint/2010/main" val="1425485440"/>
       </p:ext>
     </p:extLst>
   </p:cSld>
@@ -9345,27 +9569,6 @@
 </file>
 
 <file path=customXml/item1.xml><?xml version="1.0" encoding="utf-8"?>
-<sax_Colors>
-  <Line size="7">
-    <Color val="9e2896" tooltip="Bosch Purple 40"/>
-    <Color val="551151" tooltip="Bosch Purple 20"/>
-  </Line>
-  <Line size="7">
-    <Color val="007bc0" tooltip="Bosch Blue 50"/>
-    <Color val="004975" tooltip="Bosch Blue 30"/>
-  </Line>
-  <Line size="7">
-    <Color val="18837e" tooltip="Bosch Turquoise 50"/>
-    <Color val="0a4f4b" tooltip="Bosch Turquoise 30"/>
-  </Line>
-  <Line size="7">
-    <Color val="00884a" tooltip="Bosch Green 50"/>
-    <Color val="00512a" tooltip="Bosch Green 30"/>
-  </Line>
-</sax_Colors>
-</file>
-
-<file path=customXml/item2.xml><?xml version="1.0" encoding="utf-8"?>
 <saxML>
   <saxMLTemplate>presentation_169</saxMLTemplate>
   <Variablen>
@@ -9538,14 +9741,35 @@
 </saxML>
 </file>
 
+<file path=customXml/item2.xml><?xml version="1.0" encoding="utf-8"?>
+<sax_Colors>
+  <Line size="7">
+    <Color val="9e2896" tooltip="Bosch Purple 40"/>
+    <Color val="551151" tooltip="Bosch Purple 20"/>
+  </Line>
+  <Line size="7">
+    <Color val="007bc0" tooltip="Bosch Blue 50"/>
+    <Color val="004975" tooltip="Bosch Blue 30"/>
+  </Line>
+  <Line size="7">
+    <Color val="18837e" tooltip="Bosch Turquoise 50"/>
+    <Color val="0a4f4b" tooltip="Bosch Turquoise 30"/>
+  </Line>
+  <Line size="7">
+    <Color val="00884a" tooltip="Bosch Green 50"/>
+    <Color val="00512a" tooltip="Bosch Green 30"/>
+  </Line>
+</sax_Colors>
+</file>
+
 <file path=customXml/itemProps1.xml><?xml version="1.0" encoding="utf-8"?>
-<ds:datastoreItem xmlns:ds="http://schemas.openxmlformats.org/officeDocument/2006/customXml" ds:itemID="{D0252559-44F8-474C-B66D-E357B88E32C2}">
+<ds:datastoreItem xmlns:ds="http://schemas.openxmlformats.org/officeDocument/2006/customXml" ds:itemID="{304CF217-3C90-4AA0-B541-CE45F9BD305E}">
   <ds:schemaRefs/>
 </ds:datastoreItem>
 </file>
 
 <file path=customXml/itemProps2.xml><?xml version="1.0" encoding="utf-8"?>
-<ds:datastoreItem xmlns:ds="http://schemas.openxmlformats.org/officeDocument/2006/customXml" ds:itemID="{304CF217-3C90-4AA0-B541-CE45F9BD305E}">
+<ds:datastoreItem xmlns:ds="http://schemas.openxmlformats.org/officeDocument/2006/customXml" ds:itemID="{D0252559-44F8-474C-B66D-E357B88E32C2}">
   <ds:schemaRefs/>
 </ds:datastoreItem>
 </file>
</xml_diff>